<commit_message>
Update project submission PPT
</commit_message>
<xml_diff>
--- a/SafeSurge_AI_Project_Submission.pptx
+++ b/SafeSurge_AI_Project_Submission.pptx
@@ -7776,6 +7776,63 @@
           </a:prstGeom>
         </p:spPr>
       </p:pic>
+      <p:sp>
+        <p:nvSpPr>
+          <p:cNvPr id="2" name="TextBox 1">
+            <a:extLst>
+              <a:ext uri="{FF2B5EF4-FFF2-40B4-BE49-F238E27FC236}">
+                <a16:creationId xmlns:a16="http://schemas.microsoft.com/office/drawing/2014/main" id="{BEE1E4D6-E7EC-FBB6-28DB-88014A27050E}"/>
+              </a:ext>
+            </a:extLst>
+          </p:cNvPr>
+          <p:cNvSpPr txBox="1"/>
+          <p:nvPr/>
+        </p:nvSpPr>
+        <p:spPr>
+          <a:xfrm>
+            <a:off x="1299257" y="5300915"/>
+            <a:ext cx="5038531" cy="1015663"/>
+          </a:xfrm>
+          <a:prstGeom prst="rect">
+            <a:avLst/>
+          </a:prstGeom>
+          <a:noFill/>
+        </p:spPr>
+        <p:txBody>
+          <a:bodyPr wrap="square" rtlCol="0">
+            <a:spAutoFit/>
+          </a:bodyPr>
+          <a:lstStyle/>
+          <a:p>
+            <a:r>
+              <a:rPr lang="en-IN" sz="2400" b="1" dirty="0"/>
+              <a:t>Team members:</a:t>
+            </a:r>
+            <a:br>
+              <a:rPr lang="en-IN" b="1" dirty="0"/>
+            </a:br>
+            <a:r>
+              <a:rPr lang="en-IN" b="1" dirty="0"/>
+              <a:t>1. Omkar Shyam Gunde</a:t>
+            </a:r>
+            <a:br>
+              <a:rPr lang="en-IN" b="1" dirty="0"/>
+            </a:br>
+            <a:r>
+              <a:rPr lang="en-IN" b="1" dirty="0"/>
+              <a:t>2. </a:t>
+            </a:r>
+            <a:r>
+              <a:rPr lang="en-IN" b="1" dirty="0" err="1"/>
+              <a:t>Ridam</a:t>
+            </a:r>
+            <a:r>
+              <a:rPr lang="en-IN" b="1" dirty="0"/>
+              <a:t> Saxena</a:t>
+            </a:r>
+          </a:p>
+        </p:txBody>
+      </p:sp>
     </p:spTree>
   </p:cSld>
   <p:clrMapOvr>

</xml_diff>

<commit_message>
updated project submission ppt
</commit_message>
<xml_diff>
--- a/SafeSurge_AI_Project_Submission.pptx
+++ b/SafeSurge_AI_Project_Submission.pptx
@@ -7791,7 +7791,7 @@
         <p:spPr>
           <a:xfrm>
             <a:off x="1299257" y="5300915"/>
-            <a:ext cx="5038531" cy="1015663"/>
+            <a:ext cx="5038531" cy="1292662"/>
           </a:xfrm>
           <a:prstGeom prst="rect">
             <a:avLst/>
@@ -7829,6 +7829,12 @@
             <a:r>
               <a:rPr lang="en-IN" b="1" dirty="0"/>
               <a:t> Saxena</a:t>
+            </a:r>
+          </a:p>
+          <a:p>
+            <a:r>
+              <a:rPr lang="en-IN" b="1" dirty="0"/>
+              <a:t>3. Prem Arvind Patil</a:t>
             </a:r>
           </a:p>
         </p:txBody>

</xml_diff>